<commit_message>
Moving cat outside the antupy folder, into the dev folder. Other changes, going to version 0.6.0
</commit_message>
<xml_diff>
--- a/tuts/prezzo/antupy.pptx
+++ b/tuts/prezzo/antupy.pptx
@@ -354,7 +354,7 @@
           <a:p>
             <a:fld id="{BA80F017-51D9-403D-A3B1-D86CBEE1772E}" type="datetimeFigureOut">
               <a:rPr lang="en-AU" smtClean="0"/>
-              <a:t>17/04/2026</a:t>
+              <a:t>5/05/2026</a:t>
             </a:fld>
             <a:endParaRPr lang="en-AU"/>
           </a:p>
@@ -554,7 +554,7 @@
           <a:p>
             <a:fld id="{BA80F017-51D9-403D-A3B1-D86CBEE1772E}" type="datetimeFigureOut">
               <a:rPr lang="en-AU" smtClean="0"/>
-              <a:t>17/04/2026</a:t>
+              <a:t>5/05/2026</a:t>
             </a:fld>
             <a:endParaRPr lang="en-AU"/>
           </a:p>
@@ -764,7 +764,7 @@
           <a:p>
             <a:fld id="{BA80F017-51D9-403D-A3B1-D86CBEE1772E}" type="datetimeFigureOut">
               <a:rPr lang="en-AU" smtClean="0"/>
-              <a:t>17/04/2026</a:t>
+              <a:t>5/05/2026</a:t>
             </a:fld>
             <a:endParaRPr lang="en-AU"/>
           </a:p>
@@ -964,7 +964,7 @@
           <a:p>
             <a:fld id="{BA80F017-51D9-403D-A3B1-D86CBEE1772E}" type="datetimeFigureOut">
               <a:rPr lang="en-AU" smtClean="0"/>
-              <a:t>17/04/2026</a:t>
+              <a:t>5/05/2026</a:t>
             </a:fld>
             <a:endParaRPr lang="en-AU"/>
           </a:p>
@@ -1240,7 +1240,7 @@
           <a:p>
             <a:fld id="{BA80F017-51D9-403D-A3B1-D86CBEE1772E}" type="datetimeFigureOut">
               <a:rPr lang="en-AU" smtClean="0"/>
-              <a:t>17/04/2026</a:t>
+              <a:t>5/05/2026</a:t>
             </a:fld>
             <a:endParaRPr lang="en-AU"/>
           </a:p>
@@ -1508,7 +1508,7 @@
           <a:p>
             <a:fld id="{BA80F017-51D9-403D-A3B1-D86CBEE1772E}" type="datetimeFigureOut">
               <a:rPr lang="en-AU" smtClean="0"/>
-              <a:t>17/04/2026</a:t>
+              <a:t>5/05/2026</a:t>
             </a:fld>
             <a:endParaRPr lang="en-AU"/>
           </a:p>
@@ -1923,7 +1923,7 @@
           <a:p>
             <a:fld id="{BA80F017-51D9-403D-A3B1-D86CBEE1772E}" type="datetimeFigureOut">
               <a:rPr lang="en-AU" smtClean="0"/>
-              <a:t>17/04/2026</a:t>
+              <a:t>5/05/2026</a:t>
             </a:fld>
             <a:endParaRPr lang="en-AU"/>
           </a:p>
@@ -2065,7 +2065,7 @@
           <a:p>
             <a:fld id="{BA80F017-51D9-403D-A3B1-D86CBEE1772E}" type="datetimeFigureOut">
               <a:rPr lang="en-AU" smtClean="0"/>
-              <a:t>17/04/2026</a:t>
+              <a:t>5/05/2026</a:t>
             </a:fld>
             <a:endParaRPr lang="en-AU"/>
           </a:p>
@@ -2178,7 +2178,7 @@
           <a:p>
             <a:fld id="{BA80F017-51D9-403D-A3B1-D86CBEE1772E}" type="datetimeFigureOut">
               <a:rPr lang="en-AU" smtClean="0"/>
-              <a:t>17/04/2026</a:t>
+              <a:t>5/05/2026</a:t>
             </a:fld>
             <a:endParaRPr lang="en-AU"/>
           </a:p>
@@ -2491,7 +2491,7 @@
           <a:p>
             <a:fld id="{BA80F017-51D9-403D-A3B1-D86CBEE1772E}" type="datetimeFigureOut">
               <a:rPr lang="en-AU" smtClean="0"/>
-              <a:t>17/04/2026</a:t>
+              <a:t>5/05/2026</a:t>
             </a:fld>
             <a:endParaRPr lang="en-AU"/>
           </a:p>
@@ -2780,7 +2780,7 @@
           <a:p>
             <a:fld id="{BA80F017-51D9-403D-A3B1-D86CBEE1772E}" type="datetimeFigureOut">
               <a:rPr lang="en-AU" smtClean="0"/>
-              <a:t>17/04/2026</a:t>
+              <a:t>5/05/2026</a:t>
             </a:fld>
             <a:endParaRPr lang="en-AU"/>
           </a:p>
@@ -3023,7 +3023,7 @@
           <a:p>
             <a:fld id="{BA80F017-51D9-403D-A3B1-D86CBEE1772E}" type="datetimeFigureOut">
               <a:rPr lang="en-AU" smtClean="0"/>
-              <a:t>17/04/2026</a:t>
+              <a:t>5/05/2026</a:t>
             </a:fld>
             <a:endParaRPr lang="en-AU"/>
           </a:p>
@@ -3824,7 +3824,7 @@
           <a:p>
             <a:r>
               <a:rPr lang="en-US" i="1" noProof="1"/>
-              <a:t>antü</a:t>
+              <a:t>antü-</a:t>
             </a:r>
             <a:r>
               <a:rPr lang="en-US" noProof="1"/>
@@ -3844,7 +3844,7 @@
           <a:p>
             <a:r>
               <a:rPr lang="en-US" i="1" noProof="1"/>
-              <a:t>py</a:t>
+              <a:t>-py</a:t>
             </a:r>
             <a:r>
               <a:rPr lang="en-US" noProof="1"/>
@@ -5944,7 +5944,7 @@
                     <a:schemeClr val="accent5"/>
                   </a:solidFill>
                 </a:rPr>
-                <a:t>Plant</a:t>
+                <a:t>Simulation / Plant</a:t>
               </a:r>
             </a:p>
           </p:txBody>

</xml_diff>